<commit_message>
docs(deck): enxuga slide 1 e o fecho do slide 2
Slide 1 fica so com a tese, sem subtitulo e sem paragrafo de apoio — a frase
sozinha em tela cheia, que era a direcao original da marca. No PPTX a fonte
sobe de 40 para 48pt, ja que agora ela ocupa o slide inteiro.

Slide 2 perde a explicacao sobre contrato tipado e mantem so a linha amarela:
"Nenhuma etapa espera humano para comecar a proxima."

HTML, PDF e PPTX regerados juntos a partir da mesma fonte.

Co-Authored-By: Claude Opus 5 <noreply@anthropic.com>
</commit_message>
<xml_diff>
--- a/deck/BrandLoop-deck.pptx
+++ b/deck/BrandLoop-deck.pptx
@@ -4092,8 +4092,8 @@
         </p:nvSpPr>
         <p:spPr>
           <a:xfrm>
-            <a:off x="685800" y="1371600"/>
-            <a:ext cx="10820095" cy="2011680"/>
+            <a:off x="685800" y="2377440"/>
+            <a:ext cx="10820095" cy="2377440"/>
           </a:xfrm>
           <a:prstGeom prst="rect">
             <a:avLst/>
@@ -4112,7 +4112,7 @@
               </a:lnSpc>
             </a:pPr>
             <a:r>
-              <a:rPr sz="4000" b="1">
+              <a:rPr sz="4800" b="1">
                 <a:solidFill>
                   <a:srgbClr val="F3EFE5"/>
                 </a:solidFill>
@@ -4128,91 +4128,13 @@
               </a:lnSpc>
             </a:pPr>
             <a:r>
-              <a:rPr sz="4000" b="1">
+              <a:rPr sz="4800" b="1">
                 <a:solidFill>
                   <a:srgbClr val="FFD400"/>
                 </a:solidFill>
                 <a:latin typeface="Arial"/>
               </a:rPr>
               <a:t>E todo anúncio a parecer igual.</a:t>
-            </a:r>
-          </a:p>
-        </p:txBody>
-      </p:sp>
-      <p:sp>
-        <p:nvSpPr>
-          <p:cNvPr id="5" name="TextBox 4"/>
-          <p:cNvSpPr txBox="1"/>
-          <p:nvPr/>
-        </p:nvSpPr>
-        <p:spPr>
-          <a:xfrm>
-            <a:off x="685800" y="3657600"/>
-            <a:ext cx="7863840" cy="914400"/>
-          </a:xfrm>
-          <a:prstGeom prst="rect">
-            <a:avLst/>
-          </a:prstGeom>
-          <a:noFill/>
-        </p:spPr>
-        <p:txBody>
-          <a:bodyPr wrap="square" anchor="t" lIns="0" rIns="0" tIns="0" bIns="0">
-            <a:spAutoFit/>
-          </a:bodyPr>
-          <a:lstStyle/>
-          <a:p>
-            <a:pPr algn="l">
-              <a:lnSpc>
-                <a:spcPct val="105000"/>
-              </a:lnSpc>
-            </a:pPr>
-            <a:r>
-              <a:rPr sz="2600" b="1">
-                <a:solidFill>
-                  <a:srgbClr val="F3EFE5"/>
-                </a:solidFill>
-                <a:latin typeface="Arial"/>
-              </a:rPr>
-              <a:t>Produzir não é mais a vantagem. Ser reconhecível é.</a:t>
-            </a:r>
-          </a:p>
-        </p:txBody>
-      </p:sp>
-      <p:sp>
-        <p:nvSpPr>
-          <p:cNvPr id="6" name="TextBox 5"/>
-          <p:cNvSpPr txBox="1"/>
-          <p:nvPr/>
-        </p:nvSpPr>
-        <p:spPr>
-          <a:xfrm>
-            <a:off x="685800" y="4800600"/>
-            <a:ext cx="7863840" cy="1097280"/>
-          </a:xfrm>
-          <a:prstGeom prst="rect">
-            <a:avLst/>
-          </a:prstGeom>
-          <a:noFill/>
-        </p:spPr>
-        <p:txBody>
-          <a:bodyPr wrap="square" anchor="t" lIns="0" rIns="0" tIns="0" bIns="0">
-            <a:spAutoFit/>
-          </a:bodyPr>
-          <a:lstStyle/>
-          <a:p>
-            <a:pPr algn="l">
-              <a:lnSpc>
-                <a:spcPct val="135000"/>
-              </a:lnSpc>
-            </a:pPr>
-            <a:r>
-              <a:rPr sz="1300" b="0">
-                <a:solidFill>
-                  <a:srgbClr val="A8A49B"/>
-                </a:solidFill>
-                <a:latin typeface="Arial"/>
-              </a:rPr>
-              <a:t>Quando a mesma lógica e o mesmo prompt alimentam todo mundo, as marcas viram variação do mesmo template. Produzir ficou barato. Uma marca genérica continua cara.</a:t>
             </a:r>
           </a:p>
         </p:txBody>
@@ -5525,16 +5447,7 @@
               </a:lnSpc>
             </a:pPr>
             <a:r>
-              <a:rPr sz="1200" b="0">
-                <a:solidFill>
-                  <a:srgbClr val="A8A49B"/>
-                </a:solidFill>
-                <a:latin typeface="Arial"/>
-              </a:rPr>
-              <a:t>Nenhum agente conhece o outro — cada um recebe e devolve um contrato tipado. </a:t>
-            </a:r>
-            <a:r>
-              <a:rPr sz="1200" b="0">
+              <a:rPr sz="1300" b="0">
                 <a:solidFill>
                   <a:srgbClr val="FFD400"/>
                 </a:solidFill>

</xml_diff>

<commit_message>
docs(deck): custo de US$ 0,89 no slide da Gorilla e no de negocio
Slide 4 ganha o quarto indicador, "US$ 0,89 — custo total", e ele e o unico
em amarelo da grade: e o numero que mais surpreende, e o argumento passa a ser
rapido E barato, nao so rapido.

Slide 6 ganha a linha "Custo de execucao": a mesma cifra, com o enquadramento
que importa para banca — medido, nao estimado. E o unico numero financeiro do
deck que o time consegue defender com recibo, entao e o unico que entra.

PPTX: a linha extra empurrava a ultima do slide 6 para fora do canvas. Passo
das linhas cai de 0,92 para 0,82 pol e o bloco comeca em 2,05. Verificado:
zero shapes fora do canvas.

Co-Authored-By: Claude Opus 5 <noreply@anthropic.com>
</commit_message>
<xml_diff>
--- a/deck/BrandLoop-deck.pptx
+++ b/deck/BrandLoop-deck.pptx
@@ -6270,7 +6270,7 @@
         <p:spPr>
           <a:xfrm>
             <a:off x="685800" y="3611880"/>
-            <a:ext cx="3520440" cy="1371600"/>
+            <a:ext cx="2567863" cy="1371600"/>
           </a:xfrm>
           <a:prstGeom prst="rect">
             <a:avLst/>
@@ -6313,8 +6313,8 @@
         </p:nvSpPr>
         <p:spPr>
           <a:xfrm>
-            <a:off x="914400" y="3840480"/>
-            <a:ext cx="3063240" cy="640080"/>
+            <a:off x="886968" y="3840480"/>
+            <a:ext cx="2165527" cy="640080"/>
           </a:xfrm>
           <a:prstGeom prst="rect">
             <a:avLst/>
@@ -6329,7 +6329,7 @@
           <a:p>
             <a:pPr algn="l"/>
             <a:r>
-              <a:rPr sz="3400" b="1">
+              <a:rPr sz="2800" b="1">
                 <a:solidFill>
                   <a:srgbClr val="F3EFE5"/>
                 </a:solidFill>
@@ -6348,8 +6348,8 @@
         </p:nvSpPr>
         <p:spPr>
           <a:xfrm>
-            <a:off x="914400" y="4526280"/>
-            <a:ext cx="3063240" cy="274320"/>
+            <a:off x="886968" y="4526280"/>
+            <a:ext cx="2165527" cy="320040"/>
           </a:xfrm>
           <a:prstGeom prst="rect">
             <a:avLst/>
@@ -6364,7 +6364,7 @@
           <a:p>
             <a:pPr algn="l"/>
             <a:r>
-              <a:rPr sz="900" b="0" spc="120">
+              <a:rPr sz="850" b="0" spc="120">
                 <a:solidFill>
                   <a:srgbClr val="8A8A86"/>
                 </a:solidFill>
@@ -6383,8 +6383,8 @@
         </p:nvSpPr>
         <p:spPr>
           <a:xfrm>
-            <a:off x="4407408" y="3611880"/>
-            <a:ext cx="3520440" cy="1371600"/>
+            <a:off x="3436543" y="3611880"/>
+            <a:ext cx="2567863" cy="1371600"/>
           </a:xfrm>
           <a:prstGeom prst="rect">
             <a:avLst/>
@@ -6427,8 +6427,8 @@
         </p:nvSpPr>
         <p:spPr>
           <a:xfrm>
-            <a:off x="4636008" y="3840480"/>
-            <a:ext cx="3063240" cy="640080"/>
+            <a:off x="3637711" y="3840480"/>
+            <a:ext cx="2165527" cy="640080"/>
           </a:xfrm>
           <a:prstGeom prst="rect">
             <a:avLst/>
@@ -6443,7 +6443,7 @@
           <a:p>
             <a:pPr algn="l"/>
             <a:r>
-              <a:rPr sz="3400" b="1">
+              <a:rPr sz="2800" b="1">
                 <a:solidFill>
                   <a:srgbClr val="F3EFE5"/>
                 </a:solidFill>
@@ -6462,8 +6462,8 @@
         </p:nvSpPr>
         <p:spPr>
           <a:xfrm>
-            <a:off x="4636008" y="4526280"/>
-            <a:ext cx="3063240" cy="274320"/>
+            <a:off x="3637711" y="4526280"/>
+            <a:ext cx="2165527" cy="320040"/>
           </a:xfrm>
           <a:prstGeom prst="rect">
             <a:avLst/>
@@ -6478,7 +6478,7 @@
           <a:p>
             <a:pPr algn="l"/>
             <a:r>
-              <a:rPr sz="900" b="0" spc="120">
+              <a:rPr sz="850" b="0" spc="120">
                 <a:solidFill>
                   <a:srgbClr val="8A8A86"/>
                 </a:solidFill>
@@ -6497,8 +6497,8 @@
         </p:nvSpPr>
         <p:spPr>
           <a:xfrm>
-            <a:off x="8129016" y="3611880"/>
-            <a:ext cx="3520440" cy="1371600"/>
+            <a:off x="6187287" y="3611880"/>
+            <a:ext cx="2567863" cy="1371600"/>
           </a:xfrm>
           <a:prstGeom prst="rect">
             <a:avLst/>
@@ -6541,8 +6541,8 @@
         </p:nvSpPr>
         <p:spPr>
           <a:xfrm>
-            <a:off x="8357616" y="3840480"/>
-            <a:ext cx="3063240" cy="640080"/>
+            <a:off x="6388455" y="3840480"/>
+            <a:ext cx="2165527" cy="640080"/>
           </a:xfrm>
           <a:prstGeom prst="rect">
             <a:avLst/>
@@ -6557,7 +6557,7 @@
           <a:p>
             <a:pPr algn="l"/>
             <a:r>
-              <a:rPr sz="3400" b="1">
+              <a:rPr sz="2800" b="1">
                 <a:solidFill>
                   <a:srgbClr val="F3EFE5"/>
                 </a:solidFill>
@@ -6576,8 +6576,8 @@
         </p:nvSpPr>
         <p:spPr>
           <a:xfrm>
-            <a:off x="8357616" y="4526280"/>
-            <a:ext cx="3063240" cy="274320"/>
+            <a:off x="6388455" y="4526280"/>
+            <a:ext cx="2165527" cy="320040"/>
           </a:xfrm>
           <a:prstGeom prst="rect">
             <a:avLst/>
@@ -6592,7 +6592,7 @@
           <a:p>
             <a:pPr algn="l"/>
             <a:r>
-              <a:rPr sz="900" b="0" spc="120">
+              <a:rPr sz="850" b="0" spc="120">
                 <a:solidFill>
                   <a:srgbClr val="8A8A86"/>
                 </a:solidFill>
@@ -6605,7 +6605,121 @@
       </p:sp>
       <p:sp>
         <p:nvSpPr>
-          <p:cNvPr id="18" name="TextBox 17"/>
+          <p:cNvPr id="18" name="Rectangle 17"/>
+          <p:cNvSpPr/>
+          <p:nvPr/>
+        </p:nvSpPr>
+        <p:spPr>
+          <a:xfrm>
+            <a:off x="8938031" y="3611880"/>
+            <a:ext cx="2567863" cy="1371600"/>
+          </a:xfrm>
+          <a:prstGeom prst="rect">
+            <a:avLst/>
+          </a:prstGeom>
+          <a:solidFill>
+            <a:srgbClr val="161616"/>
+          </a:solidFill>
+          <a:ln>
+            <a:noFill/>
+          </a:ln>
+          <a:effectLst/>
+        </p:spPr>
+        <p:style>
+          <a:lnRef idx="1">
+            <a:schemeClr val="accent1"/>
+          </a:lnRef>
+          <a:fillRef idx="3">
+            <a:schemeClr val="accent1"/>
+          </a:fillRef>
+          <a:effectRef idx="2">
+            <a:schemeClr val="accent1"/>
+          </a:effectRef>
+          <a:fontRef idx="minor">
+            <a:schemeClr val="lt1"/>
+          </a:fontRef>
+        </p:style>
+        <p:txBody>
+          <a:bodyPr rtlCol="0" anchor="ctr"/>
+          <a:lstStyle/>
+          <a:p>
+            <a:pPr algn="ctr"/>
+          </a:p>
+        </p:txBody>
+      </p:sp>
+      <p:sp>
+        <p:nvSpPr>
+          <p:cNvPr id="19" name="TextBox 18"/>
+          <p:cNvSpPr txBox="1"/>
+          <p:nvPr/>
+        </p:nvSpPr>
+        <p:spPr>
+          <a:xfrm>
+            <a:off x="9139199" y="3840480"/>
+            <a:ext cx="2165527" cy="640080"/>
+          </a:xfrm>
+          <a:prstGeom prst="rect">
+            <a:avLst/>
+          </a:prstGeom>
+          <a:noFill/>
+        </p:spPr>
+        <p:txBody>
+          <a:bodyPr wrap="square" anchor="t" lIns="0" rIns="0" tIns="0" bIns="0">
+            <a:spAutoFit/>
+          </a:bodyPr>
+          <a:lstStyle/>
+          <a:p>
+            <a:pPr algn="l"/>
+            <a:r>
+              <a:rPr sz="2800" b="1">
+                <a:solidFill>
+                  <a:srgbClr val="FFD400"/>
+                </a:solidFill>
+                <a:latin typeface="Arial"/>
+              </a:rPr>
+              <a:t>US$ 0,89</a:t>
+            </a:r>
+          </a:p>
+        </p:txBody>
+      </p:sp>
+      <p:sp>
+        <p:nvSpPr>
+          <p:cNvPr id="20" name="TextBox 19"/>
+          <p:cNvSpPr txBox="1"/>
+          <p:nvPr/>
+        </p:nvSpPr>
+        <p:spPr>
+          <a:xfrm>
+            <a:off x="9139199" y="4526280"/>
+            <a:ext cx="2165527" cy="320040"/>
+          </a:xfrm>
+          <a:prstGeom prst="rect">
+            <a:avLst/>
+          </a:prstGeom>
+          <a:noFill/>
+        </p:spPr>
+        <p:txBody>
+          <a:bodyPr wrap="square" anchor="t" lIns="0" rIns="0" tIns="0" bIns="0">
+            <a:spAutoFit/>
+          </a:bodyPr>
+          <a:lstStyle/>
+          <a:p>
+            <a:pPr algn="l"/>
+            <a:r>
+              <a:rPr sz="850" b="0" spc="120">
+                <a:solidFill>
+                  <a:srgbClr val="8A8A86"/>
+                </a:solidFill>
+                <a:latin typeface="Courier New"/>
+              </a:rPr>
+              <a:t>CUSTO TOTAL</a:t>
+            </a:r>
+          </a:p>
+        </p:txBody>
+      </p:sp>
+      <p:sp>
+        <p:nvSpPr>
+          <p:cNvPr id="21" name="TextBox 20"/>
           <p:cNvSpPr txBox="1"/>
           <p:nvPr/>
         </p:nvSpPr>
@@ -8132,8 +8246,8 @@
         </p:nvSpPr>
         <p:spPr>
           <a:xfrm>
-            <a:off x="685800" y="2148840"/>
-            <a:ext cx="2377440" cy="320040"/>
+            <a:off x="685800" y="1874519"/>
+            <a:ext cx="2377440" cy="292608"/>
           </a:xfrm>
           <a:prstGeom prst="rect">
             <a:avLst/>
@@ -8148,7 +8262,7 @@
           <a:p>
             <a:pPr algn="l"/>
             <a:r>
-              <a:rPr sz="950" b="0" spc="120">
+              <a:rPr sz="900" b="0" spc="120">
                 <a:solidFill>
                   <a:srgbClr val="8A8A86"/>
                 </a:solidFill>
@@ -8167,8 +8281,8 @@
         </p:nvSpPr>
         <p:spPr>
           <a:xfrm>
-            <a:off x="3246120" y="2112264"/>
-            <a:ext cx="8259775" cy="731520"/>
+            <a:off x="3246120" y="1837943"/>
+            <a:ext cx="8259775" cy="658368"/>
           </a:xfrm>
           <a:prstGeom prst="rect">
             <a:avLst/>
@@ -8183,11 +8297,11 @@
           <a:p>
             <a:pPr algn="l">
               <a:lnSpc>
-                <a:spcPct val="130000"/>
+                <a:spcPct val="128000"/>
               </a:lnSpc>
             </a:pPr>
             <a:r>
-              <a:rPr sz="1300" b="0">
+              <a:rPr sz="1250" b="0">
                 <a:solidFill>
                   <a:srgbClr val="F3EFE5"/>
                 </a:solidFill>
@@ -8206,7 +8320,7 @@
         </p:nvSpPr>
         <p:spPr>
           <a:xfrm>
-            <a:off x="685800" y="2715768"/>
+            <a:off x="685800" y="2404872"/>
             <a:ext cx="10820095" cy="10972"/>
           </a:xfrm>
           <a:prstGeom prst="rect">
@@ -8250,8 +8364,8 @@
         </p:nvSpPr>
         <p:spPr>
           <a:xfrm>
-            <a:off x="685800" y="2990088"/>
-            <a:ext cx="2377440" cy="320040"/>
+            <a:off x="685800" y="2624327"/>
+            <a:ext cx="2377440" cy="292608"/>
           </a:xfrm>
           <a:prstGeom prst="rect">
             <a:avLst/>
@@ -8266,7 +8380,7 @@
           <a:p>
             <a:pPr algn="l"/>
             <a:r>
-              <a:rPr sz="950" b="0" spc="120">
+              <a:rPr sz="900" b="0" spc="120">
                 <a:solidFill>
                   <a:srgbClr val="8A8A86"/>
                 </a:solidFill>
@@ -8285,8 +8399,8 @@
         </p:nvSpPr>
         <p:spPr>
           <a:xfrm>
-            <a:off x="3246120" y="2953512"/>
-            <a:ext cx="8259775" cy="731520"/>
+            <a:off x="3246120" y="2587751"/>
+            <a:ext cx="8259775" cy="658368"/>
           </a:xfrm>
           <a:prstGeom prst="rect">
             <a:avLst/>
@@ -8301,11 +8415,11 @@
           <a:p>
             <a:pPr algn="l">
               <a:lnSpc>
-                <a:spcPct val="130000"/>
+                <a:spcPct val="128000"/>
               </a:lnSpc>
             </a:pPr>
             <a:r>
-              <a:rPr sz="1300" b="0">
+              <a:rPr sz="1250" b="0">
                 <a:solidFill>
                   <a:srgbClr val="F3EFE5"/>
                 </a:solidFill>
@@ -8324,7 +8438,7 @@
         </p:nvSpPr>
         <p:spPr>
           <a:xfrm>
-            <a:off x="685800" y="3557016"/>
+            <a:off x="685800" y="3154679"/>
             <a:ext cx="10820095" cy="10972"/>
           </a:xfrm>
           <a:prstGeom prst="rect">
@@ -8368,8 +8482,8 @@
         </p:nvSpPr>
         <p:spPr>
           <a:xfrm>
-            <a:off x="685800" y="3831336"/>
-            <a:ext cx="2377440" cy="320040"/>
+            <a:off x="685800" y="3374135"/>
+            <a:ext cx="2377440" cy="292608"/>
           </a:xfrm>
           <a:prstGeom prst="rect">
             <a:avLst/>
@@ -8384,7 +8498,7 @@
           <a:p>
             <a:pPr algn="l"/>
             <a:r>
-              <a:rPr sz="950" b="0" spc="120">
+              <a:rPr sz="900" b="0" spc="120">
                 <a:solidFill>
                   <a:srgbClr val="8A8A86"/>
                 </a:solidFill>
@@ -8403,8 +8517,8 @@
         </p:nvSpPr>
         <p:spPr>
           <a:xfrm>
-            <a:off x="3246120" y="3794760"/>
-            <a:ext cx="8259775" cy="731520"/>
+            <a:off x="3246120" y="3337559"/>
+            <a:ext cx="8259775" cy="658368"/>
           </a:xfrm>
           <a:prstGeom prst="rect">
             <a:avLst/>
@@ -8419,11 +8533,11 @@
           <a:p>
             <a:pPr algn="l">
               <a:lnSpc>
-                <a:spcPct val="130000"/>
+                <a:spcPct val="128000"/>
               </a:lnSpc>
             </a:pPr>
             <a:r>
-              <a:rPr sz="1300" b="0">
+              <a:rPr sz="1250" b="0">
                 <a:solidFill>
                   <a:srgbClr val="F3EFE5"/>
                 </a:solidFill>
@@ -8442,7 +8556,7 @@
         </p:nvSpPr>
         <p:spPr>
           <a:xfrm>
-            <a:off x="685800" y="4398264"/>
+            <a:off x="685800" y="3904487"/>
             <a:ext cx="10820095" cy="10972"/>
           </a:xfrm>
           <a:prstGeom prst="rect">
@@ -8486,8 +8600,8 @@
         </p:nvSpPr>
         <p:spPr>
           <a:xfrm>
-            <a:off x="685800" y="4672584"/>
-            <a:ext cx="2377440" cy="320040"/>
+            <a:off x="685800" y="4123944"/>
+            <a:ext cx="2377440" cy="292608"/>
           </a:xfrm>
           <a:prstGeom prst="rect">
             <a:avLst/>
@@ -8502,7 +8616,7 @@
           <a:p>
             <a:pPr algn="l"/>
             <a:r>
-              <a:rPr sz="950" b="0" spc="120">
+              <a:rPr sz="900" b="0" spc="120">
                 <a:solidFill>
                   <a:srgbClr val="8A8A86"/>
                 </a:solidFill>
@@ -8521,8 +8635,8 @@
         </p:nvSpPr>
         <p:spPr>
           <a:xfrm>
-            <a:off x="3246120" y="4636008"/>
-            <a:ext cx="8259775" cy="731520"/>
+            <a:off x="3246120" y="4087368"/>
+            <a:ext cx="8259775" cy="658368"/>
           </a:xfrm>
           <a:prstGeom prst="rect">
             <a:avLst/>
@@ -8537,11 +8651,11 @@
           <a:p>
             <a:pPr algn="l">
               <a:lnSpc>
-                <a:spcPct val="130000"/>
+                <a:spcPct val="128000"/>
               </a:lnSpc>
             </a:pPr>
             <a:r>
-              <a:rPr sz="1300" b="0">
+              <a:rPr sz="1250" b="0">
                 <a:solidFill>
                   <a:srgbClr val="F3EFE5"/>
                 </a:solidFill>
@@ -8560,7 +8674,7 @@
         </p:nvSpPr>
         <p:spPr>
           <a:xfrm>
-            <a:off x="685800" y="5239512"/>
+            <a:off x="685800" y="4654296"/>
             <a:ext cx="10820095" cy="10972"/>
           </a:xfrm>
           <a:prstGeom prst="rect">
@@ -8604,8 +8718,8 @@
         </p:nvSpPr>
         <p:spPr>
           <a:xfrm>
-            <a:off x="685800" y="5513832"/>
-            <a:ext cx="2377440" cy="320040"/>
+            <a:off x="685800" y="4873752"/>
+            <a:ext cx="2377440" cy="292608"/>
           </a:xfrm>
           <a:prstGeom prst="rect">
             <a:avLst/>
@@ -8620,13 +8734,13 @@
           <a:p>
             <a:pPr algn="l"/>
             <a:r>
-              <a:rPr sz="950" b="0" spc="120">
+              <a:rPr sz="900" b="0" spc="120">
                 <a:solidFill>
                   <a:srgbClr val="8A8A86"/>
                 </a:solidFill>
                 <a:latin typeface="Courier New"/>
               </a:rPr>
-              <a:t>DEFENSIBILIDADE</a:t>
+              <a:t>CUSTO DE EXECUÇÃO</a:t>
             </a:r>
           </a:p>
         </p:txBody>
@@ -8639,8 +8753,8 @@
         </p:nvSpPr>
         <p:spPr>
           <a:xfrm>
-            <a:off x="3246120" y="5477256"/>
-            <a:ext cx="8259775" cy="731520"/>
+            <a:off x="3246120" y="4837176"/>
+            <a:ext cx="8259775" cy="658368"/>
           </a:xfrm>
           <a:prstGeom prst="rect">
             <a:avLst/>
@@ -8655,17 +8769,17 @@
           <a:p>
             <a:pPr algn="l">
               <a:lnSpc>
-                <a:spcPct val="130000"/>
+                <a:spcPct val="128000"/>
               </a:lnSpc>
             </a:pPr>
             <a:r>
-              <a:rPr sz="1300" b="0">
+              <a:rPr sz="1250" b="0">
                 <a:solidFill>
                   <a:srgbClr val="F3EFE5"/>
                 </a:solidFill>
                 <a:latin typeface="Arial"/>
               </a:rPr>
-              <a:t>Cada campanha devolve o que converteu, para quem e com qual mecanismo. Copia-se o prompt numa tarde; não se copia o histórico.</a:t>
+              <a:t>Uma análise de mercado completa custou US$ 0,89. Medido, não estimado.</a:t>
             </a:r>
           </a:p>
         </p:txBody>
@@ -8678,7 +8792,125 @@
         </p:nvSpPr>
         <p:spPr>
           <a:xfrm>
-            <a:off x="685800" y="6080760"/>
+            <a:off x="685800" y="5404104"/>
+            <a:ext cx="10820095" cy="10972"/>
+          </a:xfrm>
+          <a:prstGeom prst="rect">
+            <a:avLst/>
+          </a:prstGeom>
+          <a:solidFill>
+            <a:srgbClr val="2A2A28"/>
+          </a:solidFill>
+          <a:ln>
+            <a:noFill/>
+          </a:ln>
+          <a:effectLst/>
+        </p:spPr>
+        <p:style>
+          <a:lnRef idx="1">
+            <a:schemeClr val="accent1"/>
+          </a:lnRef>
+          <a:fillRef idx="3">
+            <a:schemeClr val="accent1"/>
+          </a:fillRef>
+          <a:effectRef idx="2">
+            <a:schemeClr val="accent1"/>
+          </a:effectRef>
+          <a:fontRef idx="minor">
+            <a:schemeClr val="lt1"/>
+          </a:fontRef>
+        </p:style>
+        <p:txBody>
+          <a:bodyPr rtlCol="0" anchor="ctr"/>
+          <a:lstStyle/>
+          <a:p>
+            <a:pPr algn="ctr"/>
+          </a:p>
+        </p:txBody>
+      </p:sp>
+      <p:sp>
+        <p:nvSpPr>
+          <p:cNvPr id="20" name="TextBox 19"/>
+          <p:cNvSpPr txBox="1"/>
+          <p:nvPr/>
+        </p:nvSpPr>
+        <p:spPr>
+          <a:xfrm>
+            <a:off x="685800" y="5623560"/>
+            <a:ext cx="2377440" cy="292608"/>
+          </a:xfrm>
+          <a:prstGeom prst="rect">
+            <a:avLst/>
+          </a:prstGeom>
+          <a:noFill/>
+        </p:spPr>
+        <p:txBody>
+          <a:bodyPr wrap="square" anchor="t" lIns="0" rIns="0" tIns="0" bIns="0">
+            <a:spAutoFit/>
+          </a:bodyPr>
+          <a:lstStyle/>
+          <a:p>
+            <a:pPr algn="l"/>
+            <a:r>
+              <a:rPr sz="900" b="0" spc="120">
+                <a:solidFill>
+                  <a:srgbClr val="8A8A86"/>
+                </a:solidFill>
+                <a:latin typeface="Courier New"/>
+              </a:rPr>
+              <a:t>DEFENSIBILIDADE</a:t>
+            </a:r>
+          </a:p>
+        </p:txBody>
+      </p:sp>
+      <p:sp>
+        <p:nvSpPr>
+          <p:cNvPr id="21" name="TextBox 20"/>
+          <p:cNvSpPr txBox="1"/>
+          <p:nvPr/>
+        </p:nvSpPr>
+        <p:spPr>
+          <a:xfrm>
+            <a:off x="3246120" y="5586984"/>
+            <a:ext cx="8259775" cy="658368"/>
+          </a:xfrm>
+          <a:prstGeom prst="rect">
+            <a:avLst/>
+          </a:prstGeom>
+          <a:noFill/>
+        </p:spPr>
+        <p:txBody>
+          <a:bodyPr wrap="square" anchor="t" lIns="0" rIns="0" tIns="0" bIns="0">
+            <a:spAutoFit/>
+          </a:bodyPr>
+          <a:lstStyle/>
+          <a:p>
+            <a:pPr algn="l">
+              <a:lnSpc>
+                <a:spcPct val="128000"/>
+              </a:lnSpc>
+            </a:pPr>
+            <a:r>
+              <a:rPr sz="1250" b="0">
+                <a:solidFill>
+                  <a:srgbClr val="F3EFE5"/>
+                </a:solidFill>
+                <a:latin typeface="Arial"/>
+              </a:rPr>
+              <a:t>Cada campanha devolve o que converteu, para quem e com qual mecanismo. Copia-se o prompt numa tarde; não se copia o histórico.</a:t>
+            </a:r>
+          </a:p>
+        </p:txBody>
+      </p:sp>
+      <p:sp>
+        <p:nvSpPr>
+          <p:cNvPr id="22" name="Rectangle 21"/>
+          <p:cNvSpPr/>
+          <p:nvPr/>
+        </p:nvSpPr>
+        <p:spPr>
+          <a:xfrm>
+            <a:off x="685800" y="6153912"/>
             <a:ext cx="10820095" cy="10972"/>
           </a:xfrm>
           <a:prstGeom prst="rect">

</xml_diff>

<commit_message>
docs(deck): remove o slide de backup
O slide "nao apresentar · abrir se perguntarem" sai do deck. Ele existia para
a pergunta "o que e real e o que e simulado?", que continua respondida — mas
falada, nao projetada. O corte de real vs simulado esta em
deck/perguntas-respostas.md, pergunta 10, com um aviso de que agora nao ha
slide e quem responder precisa saber de cor.

Removido tambem o CSS que so ele usava (.backup, .chips, .chip, .real, .sim) e
o slide equivalente no gerador do PPTX. Deck fecha em 7 slides nos tres
formatos.

Novo assert no build: 'nao apresentar' na saida quebra a geracao.

Co-Authored-By: Claude Opus 5 <noreply@anthropic.com>
</commit_message>
<xml_diff>
--- a/deck/BrandLoop-deck.pptx
+++ b/deck/BrandLoop-deck.pptx
@@ -12,7 +12,6 @@
     <p:sldId id="260" r:id="rId12"/>
     <p:sldId id="261" r:id="rId13"/>
     <p:sldId id="262" r:id="rId14"/>
-    <p:sldId id="263" r:id="rId15"/>
   </p:sldIdLst>
   <p:sldSz cx="12191695" cy="6858000" type="screen4x3"/>
   <p:notesSz cx="6858000" cy="9144000"/>
@@ -930,76 +929,6 @@
           <a:p>
             <a:r>
               <a:t>2:45–3:00 — Fecho. Benchmark, não cliente.</a:t>
-            </a:r>
-          </a:p>
-        </p:txBody>
-      </p:sp>
-      <p:sp>
-        <p:nvSpPr>
-          <p:cNvPr id="4" name="Slide Number Placeholder 3"/>
-          <p:cNvSpPr>
-            <a:spLocks noGrp="1"/>
-          </p:cNvSpPr>
-          <p:nvPr>
-            <p:ph type="sldNum" idx="5" sz="quarter"/>
-          </p:nvPr>
-        </p:nvSpPr>
-        <p:spPr/>
-      </p:sp>
-    </p:spTree>
-  </p:cSld>
-  <p:clrMapOvr>
-    <a:masterClrMapping/>
-  </p:clrMapOvr>
-</p:notes>
-</file>
-
-<file path=ppt/notesSlides/notesSlide8.xml><?xml version="1.0" encoding="utf-8"?>
-<p:notes xmlns:a="http://schemas.openxmlformats.org/drawingml/2006/main" xmlns:p="http://schemas.openxmlformats.org/presentationml/2006/main" xmlns:r="http://schemas.openxmlformats.org/officeDocument/2006/relationships">
-  <p:cSld>
-    <p:spTree>
-      <p:nvGrpSpPr>
-        <p:cNvPr id="1" name=""/>
-        <p:cNvGrpSpPr/>
-        <p:nvPr/>
-      </p:nvGrpSpPr>
-      <p:grpSpPr>
-        <a:xfrm>
-          <a:off x="0" y="0"/>
-          <a:ext cx="0" cy="0"/>
-          <a:chOff x="0" y="0"/>
-          <a:chExt cx="0" cy="0"/>
-        </a:xfrm>
-      </p:grpSpPr>
-      <p:sp>
-        <p:nvSpPr>
-          <p:cNvPr id="2" name="Slide Image Placeholder 1"/>
-          <p:cNvSpPr>
-            <a:spLocks noGrp="1"/>
-          </p:cNvSpPr>
-          <p:nvPr>
-            <p:ph type="sldImg" idx="2"/>
-          </p:nvPr>
-        </p:nvSpPr>
-        <p:spPr/>
-      </p:sp>
-      <p:sp>
-        <p:nvSpPr>
-          <p:cNvPr id="3" name="Notes Placeholder 2"/>
-          <p:cNvSpPr>
-            <a:spLocks noGrp="1"/>
-          </p:cNvSpPr>
-          <p:nvPr>
-            <p:ph type="body" idx="3" sz="quarter"/>
-          </p:nvPr>
-        </p:nvSpPr>
-        <p:spPr/>
-        <p:txBody>
-          <a:bodyPr/>
-          <a:lstStyle/>
-          <a:p>
-            <a:r>
-              <a:t>Slide de backup. Só abrir se perguntarem o que é real.</a:t>
             </a:r>
           </a:p>
         </p:txBody>
@@ -9161,556 +9090,6 @@
                 <a:latin typeface="Arial"/>
               </a:rPr>
               <a:t>Não somos a agência do iFood — ele é o caso mais difícil do Brasil agora, e vocês conseguem verificar tudo o que o agente concluiu.</a:t>
-            </a:r>
-          </a:p>
-        </p:txBody>
-      </p:sp>
-    </p:spTree>
-  </p:cSld>
-  <p:clrMapOvr>
-    <a:masterClrMapping/>
-  </p:clrMapOvr>
-</p:sld>
-</file>
-
-<file path=ppt/slides/slide8.xml><?xml version="1.0" encoding="utf-8"?>
-<p:sld xmlns:a="http://schemas.openxmlformats.org/drawingml/2006/main" xmlns:p="http://schemas.openxmlformats.org/presentationml/2006/main" xmlns:r="http://schemas.openxmlformats.org/officeDocument/2006/relationships">
-  <p:cSld>
-    <p:spTree>
-      <p:nvGrpSpPr>
-        <p:cNvPr id="1" name=""/>
-        <p:cNvGrpSpPr/>
-        <p:nvPr/>
-      </p:nvGrpSpPr>
-      <p:grpSpPr/>
-      <p:sp>
-        <p:nvSpPr>
-          <p:cNvPr id="2" name="Rectangle 1"/>
-          <p:cNvSpPr/>
-          <p:nvPr/>
-        </p:nvSpPr>
-        <p:spPr>
-          <a:xfrm>
-            <a:off x="0" y="0"/>
-            <a:ext cx="12191695" cy="6858000"/>
-          </a:xfrm>
-          <a:prstGeom prst="rect">
-            <a:avLst/>
-          </a:prstGeom>
-          <a:solidFill>
-            <a:srgbClr val="0A0A0A"/>
-          </a:solidFill>
-          <a:ln>
-            <a:noFill/>
-          </a:ln>
-          <a:effectLst/>
-        </p:spPr>
-        <p:style>
-          <a:lnRef idx="1">
-            <a:schemeClr val="accent1"/>
-          </a:lnRef>
-          <a:fillRef idx="3">
-            <a:schemeClr val="accent1"/>
-          </a:fillRef>
-          <a:effectRef idx="2">
-            <a:schemeClr val="accent1"/>
-          </a:effectRef>
-          <a:fontRef idx="minor">
-            <a:schemeClr val="lt1"/>
-          </a:fontRef>
-        </p:style>
-        <p:txBody>
-          <a:bodyPr rtlCol="0" anchor="ctr"/>
-          <a:lstStyle/>
-          <a:p>
-            <a:pPr algn="ctr"/>
-          </a:p>
-        </p:txBody>
-      </p:sp>
-      <p:sp>
-        <p:nvSpPr>
-          <p:cNvPr id="3" name="TextBox 2"/>
-          <p:cNvSpPr txBox="1"/>
-          <p:nvPr/>
-        </p:nvSpPr>
-        <p:spPr>
-          <a:xfrm>
-            <a:off x="685800" y="548640"/>
-            <a:ext cx="8229600" cy="228600"/>
-          </a:xfrm>
-          <a:prstGeom prst="rect">
-            <a:avLst/>
-          </a:prstGeom>
-          <a:noFill/>
-        </p:spPr>
-        <p:txBody>
-          <a:bodyPr wrap="square" anchor="t" lIns="0" rIns="0" tIns="0" bIns="0">
-            <a:spAutoFit/>
-          </a:bodyPr>
-          <a:lstStyle/>
-          <a:p>
-            <a:pPr algn="l"/>
-            <a:r>
-              <a:rPr sz="900" b="0" spc="120">
-                <a:solidFill>
-                  <a:srgbClr val="8A8A86"/>
-                </a:solidFill>
-                <a:latin typeface="Courier New"/>
-              </a:rPr>
-              <a:t>BACKUP — NÃO APRESENTAR · ABRIR SE PERGUNTAREM</a:t>
-            </a:r>
-          </a:p>
-        </p:txBody>
-      </p:sp>
-      <p:sp>
-        <p:nvSpPr>
-          <p:cNvPr id="4" name="TextBox 3"/>
-          <p:cNvSpPr txBox="1"/>
-          <p:nvPr/>
-        </p:nvSpPr>
-        <p:spPr>
-          <a:xfrm>
-            <a:off x="685800" y="960120"/>
-            <a:ext cx="9601200" cy="731520"/>
-          </a:xfrm>
-          <a:prstGeom prst="rect">
-            <a:avLst/>
-          </a:prstGeom>
-          <a:noFill/>
-        </p:spPr>
-        <p:txBody>
-          <a:bodyPr wrap="square" anchor="t" lIns="0" rIns="0" tIns="0" bIns="0">
-            <a:spAutoFit/>
-          </a:bodyPr>
-          <a:lstStyle/>
-          <a:p>
-            <a:pPr algn="l"/>
-            <a:r>
-              <a:rPr sz="3000" b="1">
-                <a:solidFill>
-                  <a:srgbClr val="F3EFE5"/>
-                </a:solidFill>
-                <a:latin typeface="Arial"/>
-              </a:rPr>
-              <a:t>O que é real e o que é simulado</a:t>
-            </a:r>
-          </a:p>
-        </p:txBody>
-      </p:sp>
-      <p:sp>
-        <p:nvSpPr>
-          <p:cNvPr id="5" name="TextBox 4"/>
-          <p:cNvSpPr txBox="1"/>
-          <p:nvPr/>
-        </p:nvSpPr>
-        <p:spPr>
-          <a:xfrm>
-            <a:off x="685800" y="2103120"/>
-            <a:ext cx="1371600" cy="274320"/>
-          </a:xfrm>
-          <a:prstGeom prst="rect">
-            <a:avLst/>
-          </a:prstGeom>
-          <a:noFill/>
-        </p:spPr>
-        <p:txBody>
-          <a:bodyPr wrap="square" anchor="t" lIns="0" rIns="0" tIns="0" bIns="0">
-            <a:spAutoFit/>
-          </a:bodyPr>
-          <a:lstStyle/>
-          <a:p>
-            <a:pPr algn="l"/>
-            <a:r>
-              <a:rPr sz="900" b="1" spc="120">
-                <a:solidFill>
-                  <a:srgbClr val="9FF5D0"/>
-                </a:solidFill>
-                <a:latin typeface="Courier New"/>
-              </a:rPr>
-              <a:t>REAL</a:t>
-            </a:r>
-          </a:p>
-        </p:txBody>
-      </p:sp>
-      <p:sp>
-        <p:nvSpPr>
-          <p:cNvPr id="6" name="TextBox 5"/>
-          <p:cNvSpPr txBox="1"/>
-          <p:nvPr/>
-        </p:nvSpPr>
-        <p:spPr>
-          <a:xfrm>
-            <a:off x="2240280" y="2057400"/>
-            <a:ext cx="9265615" cy="548640"/>
-          </a:xfrm>
-          <a:prstGeom prst="rect">
-            <a:avLst/>
-          </a:prstGeom>
-          <a:noFill/>
-        </p:spPr>
-        <p:txBody>
-          <a:bodyPr wrap="square" anchor="t" lIns="0" rIns="0" tIns="0" bIns="0">
-            <a:spAutoFit/>
-          </a:bodyPr>
-          <a:lstStyle/>
-          <a:p>
-            <a:pPr algn="l">
-              <a:lnSpc>
-                <a:spcPct val="130000"/>
-              </a:lnSpc>
-            </a:pPr>
-            <a:r>
-              <a:rPr sz="1250" b="0">
-                <a:solidFill>
-                  <a:srgbClr val="F3EFE5"/>
-                </a:solidFill>
-                <a:latin typeface="Arial"/>
-              </a:rPr>
-              <a:t>Contexto e entrevista — /api/ingest e /api/interview, adapter Anthropic + OpenAI</a:t>
-            </a:r>
-          </a:p>
-        </p:txBody>
-      </p:sp>
-      <p:sp>
-        <p:nvSpPr>
-          <p:cNvPr id="7" name="TextBox 6"/>
-          <p:cNvSpPr txBox="1"/>
-          <p:nvPr/>
-        </p:nvSpPr>
-        <p:spPr>
-          <a:xfrm>
-            <a:off x="685800" y="2788920"/>
-            <a:ext cx="1371600" cy="274320"/>
-          </a:xfrm>
-          <a:prstGeom prst="rect">
-            <a:avLst/>
-          </a:prstGeom>
-          <a:noFill/>
-        </p:spPr>
-        <p:txBody>
-          <a:bodyPr wrap="square" anchor="t" lIns="0" rIns="0" tIns="0" bIns="0">
-            <a:spAutoFit/>
-          </a:bodyPr>
-          <a:lstStyle/>
-          <a:p>
-            <a:pPr algn="l"/>
-            <a:r>
-              <a:rPr sz="900" b="1" spc="120">
-                <a:solidFill>
-                  <a:srgbClr val="9FF5D0"/>
-                </a:solidFill>
-                <a:latin typeface="Courier New"/>
-              </a:rPr>
-              <a:t>REAL</a:t>
-            </a:r>
-          </a:p>
-        </p:txBody>
-      </p:sp>
-      <p:sp>
-        <p:nvSpPr>
-          <p:cNvPr id="8" name="TextBox 7"/>
-          <p:cNvSpPr txBox="1"/>
-          <p:nvPr/>
-        </p:nvSpPr>
-        <p:spPr>
-          <a:xfrm>
-            <a:off x="2240280" y="2743200"/>
-            <a:ext cx="9265615" cy="548640"/>
-          </a:xfrm>
-          <a:prstGeom prst="rect">
-            <a:avLst/>
-          </a:prstGeom>
-          <a:noFill/>
-        </p:spPr>
-        <p:txBody>
-          <a:bodyPr wrap="square" anchor="t" lIns="0" rIns="0" tIns="0" bIns="0">
-            <a:spAutoFit/>
-          </a:bodyPr>
-          <a:lstStyle/>
-          <a:p>
-            <a:pPr algn="l">
-              <a:lnSpc>
-                <a:spcPct val="130000"/>
-              </a:lnSpc>
-            </a:pPr>
-            <a:r>
-              <a:rPr sz="1250" b="0">
-                <a:solidFill>
-                  <a:srgbClr val="F3EFE5"/>
-                </a:solidFill>
-                <a:latin typeface="Arial"/>
-              </a:rPr>
-              <a:t>Análise de mercado — /api/research, Gorilla API, 1.516 conversas, search_id verificável</a:t>
-            </a:r>
-          </a:p>
-        </p:txBody>
-      </p:sp>
-      <p:sp>
-        <p:nvSpPr>
-          <p:cNvPr id="9" name="TextBox 8"/>
-          <p:cNvSpPr txBox="1"/>
-          <p:nvPr/>
-        </p:nvSpPr>
-        <p:spPr>
-          <a:xfrm>
-            <a:off x="685800" y="3474720"/>
-            <a:ext cx="1371600" cy="274320"/>
-          </a:xfrm>
-          <a:prstGeom prst="rect">
-            <a:avLst/>
-          </a:prstGeom>
-          <a:noFill/>
-        </p:spPr>
-        <p:txBody>
-          <a:bodyPr wrap="square" anchor="t" lIns="0" rIns="0" tIns="0" bIns="0">
-            <a:spAutoFit/>
-          </a:bodyPr>
-          <a:lstStyle/>
-          <a:p>
-            <a:pPr algn="l"/>
-            <a:r>
-              <a:rPr sz="900" b="1" spc="120">
-                <a:solidFill>
-                  <a:srgbClr val="9FF5D0"/>
-                </a:solidFill>
-                <a:latin typeface="Courier New"/>
-              </a:rPr>
-              <a:t>REAL</a:t>
-            </a:r>
-          </a:p>
-        </p:txBody>
-      </p:sp>
-      <p:sp>
-        <p:nvSpPr>
-          <p:cNvPr id="10" name="TextBox 9"/>
-          <p:cNvSpPr txBox="1"/>
-          <p:nvPr/>
-        </p:nvSpPr>
-        <p:spPr>
-          <a:xfrm>
-            <a:off x="2240280" y="3429000"/>
-            <a:ext cx="9265615" cy="548640"/>
-          </a:xfrm>
-          <a:prstGeom prst="rect">
-            <a:avLst/>
-          </a:prstGeom>
-          <a:noFill/>
-        </p:spPr>
-        <p:txBody>
-          <a:bodyPr wrap="square" anchor="t" lIns="0" rIns="0" tIns="0" bIns="0">
-            <a:spAutoFit/>
-          </a:bodyPr>
-          <a:lstStyle/>
-          <a:p>
-            <a:pPr algn="l">
-              <a:lnSpc>
-                <a:spcPct val="130000"/>
-              </a:lnSpc>
-            </a:pPr>
-            <a:r>
-              <a:rPr sz="1250" b="0">
-                <a:solidFill>
-                  <a:srgbClr val="F3EFE5"/>
-                </a:solidFill>
-                <a:latin typeface="Arial"/>
-              </a:rPr>
-              <a:t>Roteiro e criativo — /api/copy e /api/video, providers plugáveis</a:t>
-            </a:r>
-          </a:p>
-        </p:txBody>
-      </p:sp>
-      <p:sp>
-        <p:nvSpPr>
-          <p:cNvPr id="11" name="TextBox 10"/>
-          <p:cNvSpPr txBox="1"/>
-          <p:nvPr/>
-        </p:nvSpPr>
-        <p:spPr>
-          <a:xfrm>
-            <a:off x="685800" y="4160520"/>
-            <a:ext cx="1371600" cy="274320"/>
-          </a:xfrm>
-          <a:prstGeom prst="rect">
-            <a:avLst/>
-          </a:prstGeom>
-          <a:noFill/>
-        </p:spPr>
-        <p:txBody>
-          <a:bodyPr wrap="square" anchor="t" lIns="0" rIns="0" tIns="0" bIns="0">
-            <a:spAutoFit/>
-          </a:bodyPr>
-          <a:lstStyle/>
-          <a:p>
-            <a:pPr algn="l"/>
-            <a:r>
-              <a:rPr sz="900" b="1" spc="120">
-                <a:solidFill>
-                  <a:srgbClr val="8A8A86"/>
-                </a:solidFill>
-                <a:latin typeface="Courier New"/>
-              </a:rPr>
-              <a:t>SIMULADO</a:t>
-            </a:r>
-          </a:p>
-        </p:txBody>
-      </p:sp>
-      <p:sp>
-        <p:nvSpPr>
-          <p:cNvPr id="12" name="TextBox 11"/>
-          <p:cNvSpPr txBox="1"/>
-          <p:nvPr/>
-        </p:nvSpPr>
-        <p:spPr>
-          <a:xfrm>
-            <a:off x="2240280" y="4114800"/>
-            <a:ext cx="9265615" cy="548640"/>
-          </a:xfrm>
-          <a:prstGeom prst="rect">
-            <a:avLst/>
-          </a:prstGeom>
-          <a:noFill/>
-        </p:spPr>
-        <p:txBody>
-          <a:bodyPr wrap="square" anchor="t" lIns="0" rIns="0" tIns="0" bIns="0">
-            <a:spAutoFit/>
-          </a:bodyPr>
-          <a:lstStyle/>
-          <a:p>
-            <a:pPr algn="l">
-              <a:lnSpc>
-                <a:spcPct val="130000"/>
-              </a:lnSpc>
-            </a:pPr>
-            <a:r>
-              <a:rPr sz="1250" b="0">
-                <a:solidFill>
-                  <a:srgbClr val="F3EFE5"/>
-                </a:solidFill>
-                <a:latin typeface="Arial"/>
-              </a:rPr>
-              <a:t>Publicação e campanha — simulado: true forçado pelo contrato de tipos</a:t>
-            </a:r>
-          </a:p>
-        </p:txBody>
-      </p:sp>
-      <p:sp>
-        <p:nvSpPr>
-          <p:cNvPr id="13" name="TextBox 12"/>
-          <p:cNvSpPr txBox="1"/>
-          <p:nvPr/>
-        </p:nvSpPr>
-        <p:spPr>
-          <a:xfrm>
-            <a:off x="685800" y="4846320"/>
-            <a:ext cx="1371600" cy="274320"/>
-          </a:xfrm>
-          <a:prstGeom prst="rect">
-            <a:avLst/>
-          </a:prstGeom>
-          <a:noFill/>
-        </p:spPr>
-        <p:txBody>
-          <a:bodyPr wrap="square" anchor="t" lIns="0" rIns="0" tIns="0" bIns="0">
-            <a:spAutoFit/>
-          </a:bodyPr>
-          <a:lstStyle/>
-          <a:p>
-            <a:pPr algn="l"/>
-            <a:r>
-              <a:rPr sz="900" b="1" spc="120">
-                <a:solidFill>
-                  <a:srgbClr val="8A8A86"/>
-                </a:solidFill>
-                <a:latin typeface="Courier New"/>
-              </a:rPr>
-              <a:t>SIMULADO</a:t>
-            </a:r>
-          </a:p>
-        </p:txBody>
-      </p:sp>
-      <p:sp>
-        <p:nvSpPr>
-          <p:cNvPr id="14" name="TextBox 13"/>
-          <p:cNvSpPr txBox="1"/>
-          <p:nvPr/>
-        </p:nvSpPr>
-        <p:spPr>
-          <a:xfrm>
-            <a:off x="2240280" y="4800600"/>
-            <a:ext cx="9265615" cy="548640"/>
-          </a:xfrm>
-          <a:prstGeom prst="rect">
-            <a:avLst/>
-          </a:prstGeom>
-          <a:noFill/>
-        </p:spPr>
-        <p:txBody>
-          <a:bodyPr wrap="square" anchor="t" lIns="0" rIns="0" tIns="0" bIns="0">
-            <a:spAutoFit/>
-          </a:bodyPr>
-          <a:lstStyle/>
-          <a:p>
-            <a:pPr algn="l">
-              <a:lnSpc>
-                <a:spcPct val="130000"/>
-              </a:lnSpc>
-            </a:pPr>
-            <a:r>
-              <a:rPr sz="1250" b="0">
-                <a:solidFill>
-                  <a:srgbClr val="F3EFE5"/>
-                </a:solidFill>
-                <a:latin typeface="Arial"/>
-              </a:rPr>
-              <a:t>Performance — ROAS de 8 semanas não cabe em 5 horas</a:t>
-            </a:r>
-          </a:p>
-        </p:txBody>
-      </p:sp>
-      <p:sp>
-        <p:nvSpPr>
-          <p:cNvPr id="15" name="TextBox 14"/>
-          <p:cNvSpPr txBox="1"/>
-          <p:nvPr/>
-        </p:nvSpPr>
-        <p:spPr>
-          <a:xfrm>
-            <a:off x="685800" y="5715000"/>
-            <a:ext cx="10820095" cy="731520"/>
-          </a:xfrm>
-          <a:prstGeom prst="rect">
-            <a:avLst/>
-          </a:prstGeom>
-          <a:noFill/>
-        </p:spPr>
-        <p:txBody>
-          <a:bodyPr wrap="square" anchor="t" lIns="0" rIns="0" tIns="0" bIns="0">
-            <a:spAutoFit/>
-          </a:bodyPr>
-          <a:lstStyle/>
-          <a:p>
-            <a:pPr algn="l">
-              <a:lnSpc>
-                <a:spcPct val="135000"/>
-              </a:lnSpc>
-            </a:pPr>
-            <a:r>
-              <a:rPr sz="1300" b="0">
-                <a:solidFill>
-                  <a:srgbClr val="A8A49B"/>
-                </a:solidFill>
-                <a:latin typeface="Arial"/>
-              </a:rPr>
-              <a:t>A performance roda em ambiente de simulação — o mesmo harness que usaríamos para evals em produção. </a:t>
-            </a:r>
-            <a:r>
-              <a:rPr sz="1300" b="0">
-                <a:solidFill>
-                  <a:srgbClr val="FFD400"/>
-                </a:solidFill>
-                <a:latin typeface="Arial"/>
-              </a:rPr>
-              <a:t>A diferença entre esconder e escolher é o que estamos mostrando aqui.</a:t>
             </a:r>
           </a:p>
         </p:txBody>

</xml_diff>